<commit_message>
feat: architecture Big Data (Lambda) - doc + justification des choix + schema + slide
Co-authored-by: lyesatb <lyesatb@users.noreply.github.com>
</commit_message>
<xml_diff>
--- a/data/curated/reports/UrbanHub_presentation.pptx
+++ b/data/curated/reports/UrbanHub_presentation.pptx
@@ -15,6 +15,7 @@
     <p:sldId id="263" r:id="rId14"/>
     <p:sldId id="264" r:id="rId15"/>
     <p:sldId id="265" r:id="rId16"/>
+    <p:sldId id="266" r:id="rId17"/>
   </p:sldIdLst>
   <p:sldSz cx="12192000" cy="6858000" type="screen4x3"/>
   <p:notesSz cx="6858000" cy="9144000"/>
@@ -3426,6 +3427,269 @@
                 </a:solidFill>
                 <a:latin typeface="Calibri"/>
               </a:rPr>
+              <a:t>RESTITUTION</a:t>
+            </a:r>
+          </a:p>
+        </p:txBody>
+      </p:sp>
+      <p:sp>
+        <p:nvSpPr>
+          <p:cNvPr id="5" name="TextBox 4"/>
+          <p:cNvSpPr txBox="1"/>
+          <p:nvPr/>
+        </p:nvSpPr>
+        <p:spPr>
+          <a:xfrm>
+            <a:off x="500000" y="600000"/>
+            <a:ext cx="11200000" cy="700000"/>
+          </a:xfrm>
+          <a:prstGeom prst="rect">
+            <a:avLst/>
+          </a:prstGeom>
+          <a:noFill/>
+        </p:spPr>
+        <p:txBody>
+          <a:bodyPr wrap="square" anchor="t">
+            <a:spAutoFit/>
+          </a:bodyPr>
+          <a:lstStyle/>
+          <a:p>
+            <a:pPr algn="l"/>
+            <a:r>
+              <a:rPr sz="3000" b="1">
+                <a:solidFill>
+                  <a:srgbClr val="1F3B57"/>
+                </a:solidFill>
+                <a:latin typeface="Calibri"/>
+              </a:rPr>
+              <a:t>Tableau de bord interactif (Streamlit)</a:t>
+            </a:r>
+          </a:p>
+        </p:txBody>
+      </p:sp>
+      <p:sp>
+        <p:nvSpPr>
+          <p:cNvPr id="6" name="TextBox 5"/>
+          <p:cNvSpPr txBox="1"/>
+          <p:nvPr/>
+        </p:nvSpPr>
+        <p:spPr>
+          <a:xfrm>
+            <a:off x="600000" y="1600000"/>
+            <a:ext cx="11000000" cy="3000000"/>
+          </a:xfrm>
+          <a:prstGeom prst="rect">
+            <a:avLst/>
+          </a:prstGeom>
+          <a:noFill/>
+        </p:spPr>
+        <p:txBody>
+          <a:bodyPr wrap="square">
+            <a:spAutoFit/>
+          </a:bodyPr>
+          <a:lstStyle/>
+          <a:p>
+            <a:pPr>
+              <a:spcAft>
+                <a:spcPts val="600"/>
+              </a:spcAft>
+            </a:pPr>
+            <a:r>
+              <a:rPr sz="1600">
+                <a:solidFill>
+                  <a:srgbClr val="1F3B57"/>
+                </a:solidFill>
+                <a:latin typeface="Calibri"/>
+              </a:rPr>
+              <a:t>• 4 onglets : Météo · Mobilité · Pollution · Analyse croisée.</a:t>
+            </a:r>
+          </a:p>
+          <a:p>
+            <a:pPr>
+              <a:spcAft>
+                <a:spcPts val="600"/>
+              </a:spcAft>
+            </a:pPr>
+            <a:r>
+              <a:rPr sz="1600">
+                <a:solidFill>
+                  <a:srgbClr val="1F3B57"/>
+                </a:solidFill>
+                <a:latin typeface="Calibri"/>
+              </a:rPr>
+              <a:t>• Filtres interactifs (menus déroulants à cases à cocher) : villes, polluants, réseaux — les graphiques se recalculent en direct.</a:t>
+            </a:r>
+          </a:p>
+          <a:p>
+            <a:pPr>
+              <a:spcAft>
+                <a:spcPts val="600"/>
+              </a:spcAft>
+            </a:pPr>
+            <a:r>
+              <a:rPr sz="1600">
+                <a:solidFill>
+                  <a:srgbClr val="1F3B57"/>
+                </a:solidFill>
+                <a:latin typeface="Calibri"/>
+              </a:rPr>
+              <a:t>• KPIs, carte des stations vélos, classements, profils horaires, matrice de corrélation.</a:t>
+            </a:r>
+          </a:p>
+          <a:p>
+            <a:pPr>
+              <a:spcAft>
+                <a:spcPts val="600"/>
+              </a:spcAft>
+            </a:pPr>
+            <a:r>
+              <a:rPr sz="1600">
+                <a:solidFill>
+                  <a:srgbClr val="1F3B57"/>
+                </a:solidFill>
+                <a:latin typeface="Calibri"/>
+              </a:rPr>
+              <a:t>• Lancement : python -m urbanhub.cli dashboard  →  http://localhost:8501</a:t>
+            </a:r>
+          </a:p>
+        </p:txBody>
+      </p:sp>
+    </p:spTree>
+  </p:cSld>
+  <p:clrMapOvr>
+    <a:masterClrMapping/>
+  </p:clrMapOvr>
+</p:sld>
+</file>
+
+<file path=ppt/slides/slide11.xml><?xml version="1.0" encoding="utf-8"?>
+<p:sld xmlns:a="http://schemas.openxmlformats.org/drawingml/2006/main" xmlns:p="http://schemas.openxmlformats.org/presentationml/2006/main" xmlns:r="http://schemas.openxmlformats.org/officeDocument/2006/relationships">
+  <p:cSld>
+    <p:spTree>
+      <p:nvGrpSpPr>
+        <p:cNvPr id="1" name=""/>
+        <p:cNvGrpSpPr/>
+        <p:nvPr/>
+      </p:nvGrpSpPr>
+      <p:grpSpPr/>
+      <p:sp>
+        <p:nvSpPr>
+          <p:cNvPr id="2" name="Rectangle 1"/>
+          <p:cNvSpPr/>
+          <p:nvPr/>
+        </p:nvSpPr>
+        <p:spPr>
+          <a:xfrm>
+            <a:off x="0" y="0"/>
+            <a:ext cx="12192000" cy="180000"/>
+          </a:xfrm>
+          <a:prstGeom prst="rect">
+            <a:avLst/>
+          </a:prstGeom>
+          <a:solidFill>
+            <a:srgbClr val="1F3B57"/>
+          </a:solidFill>
+          <a:ln>
+            <a:noFill/>
+          </a:ln>
+          <a:effectLst/>
+        </p:spPr>
+        <p:style>
+          <a:lnRef idx="1">
+            <a:schemeClr val="accent1"/>
+          </a:lnRef>
+          <a:fillRef idx="3">
+            <a:schemeClr val="accent1"/>
+          </a:fillRef>
+          <a:effectRef idx="2">
+            <a:schemeClr val="accent1"/>
+          </a:effectRef>
+          <a:fontRef idx="minor">
+            <a:schemeClr val="lt1"/>
+          </a:fontRef>
+        </p:style>
+        <p:txBody>
+          <a:bodyPr rtlCol="0" anchor="ctr"/>
+          <a:lstStyle/>
+          <a:p>
+            <a:pPr algn="ctr"/>
+          </a:p>
+        </p:txBody>
+      </p:sp>
+      <p:sp>
+        <p:nvSpPr>
+          <p:cNvPr id="3" name="Rectangle 2"/>
+          <p:cNvSpPr/>
+          <p:nvPr/>
+        </p:nvSpPr>
+        <p:spPr>
+          <a:xfrm>
+            <a:off x="0" y="180000"/>
+            <a:ext cx="4200000" cy="30000"/>
+          </a:xfrm>
+          <a:prstGeom prst="rect">
+            <a:avLst/>
+          </a:prstGeom>
+          <a:solidFill>
+            <a:srgbClr val="2A9D8F"/>
+          </a:solidFill>
+          <a:ln>
+            <a:noFill/>
+          </a:ln>
+          <a:effectLst/>
+        </p:spPr>
+        <p:style>
+          <a:lnRef idx="1">
+            <a:schemeClr val="accent1"/>
+          </a:lnRef>
+          <a:fillRef idx="3">
+            <a:schemeClr val="accent1"/>
+          </a:fillRef>
+          <a:effectRef idx="2">
+            <a:schemeClr val="accent1"/>
+          </a:effectRef>
+          <a:fontRef idx="minor">
+            <a:schemeClr val="lt1"/>
+          </a:fontRef>
+        </p:style>
+        <p:txBody>
+          <a:bodyPr rtlCol="0" anchor="ctr"/>
+          <a:lstStyle/>
+          <a:p>
+            <a:pPr algn="ctr"/>
+          </a:p>
+        </p:txBody>
+      </p:sp>
+      <p:sp>
+        <p:nvSpPr>
+          <p:cNvPr id="4" name="TextBox 3"/>
+          <p:cNvSpPr txBox="1"/>
+          <p:nvPr/>
+        </p:nvSpPr>
+        <p:spPr>
+          <a:xfrm>
+            <a:off x="500000" y="300000"/>
+            <a:ext cx="11000000" cy="500000"/>
+          </a:xfrm>
+          <a:prstGeom prst="rect">
+            <a:avLst/>
+          </a:prstGeom>
+          <a:noFill/>
+        </p:spPr>
+        <p:txBody>
+          <a:bodyPr wrap="square" anchor="t">
+            <a:spAutoFit/>
+          </a:bodyPr>
+          <a:lstStyle/>
+          <a:p>
+            <a:pPr algn="l"/>
+            <a:r>
+              <a:rPr sz="1400" b="1">
+                <a:solidFill>
+                  <a:srgbClr val="2A9D8F"/>
+                </a:solidFill>
+                <a:latin typeface="Calibri"/>
+              </a:rPr>
               <a:t>CONCLUSION</a:t>
             </a:r>
           </a:p>
@@ -5841,7 +6105,7 @@
                 </a:solidFill>
                 <a:latin typeface="Calibri"/>
               </a:rPr>
-              <a:t>PARTIE 1 · FLUX BATCH</a:t>
+              <a:t>ARCHITECTURE BIG DATA</a:t>
             </a:r>
           </a:p>
         </p:txBody>
@@ -5876,149 +6140,14 @@
                 </a:solidFill>
                 <a:latin typeface="Calibri"/>
               </a:rPr>
-              <a:t>Analyse météorologique urbaine (NOAA)</a:t>
-            </a:r>
-          </a:p>
-        </p:txBody>
-      </p:sp>
-      <p:sp>
-        <p:nvSpPr>
-          <p:cNvPr id="6" name="TextBox 5"/>
-          <p:cNvSpPr txBox="1"/>
-          <p:nvPr/>
-        </p:nvSpPr>
-        <p:spPr>
-          <a:xfrm>
-            <a:off x="600000" y="1550000"/>
-            <a:ext cx="5600000" cy="4500000"/>
-          </a:xfrm>
-          <a:prstGeom prst="rect">
-            <a:avLst/>
-          </a:prstGeom>
-          <a:noFill/>
-        </p:spPr>
-        <p:txBody>
-          <a:bodyPr wrap="square">
-            <a:spAutoFit/>
-          </a:bodyPr>
-          <a:lstStyle/>
-          <a:p>
-            <a:pPr>
-              <a:spcAft>
-                <a:spcPts val="600"/>
-              </a:spcAft>
-            </a:pPr>
-            <a:r>
-              <a:rPr sz="1500">
-                <a:solidFill>
-                  <a:srgbClr val="1F3B57"/>
-                </a:solidFill>
-                <a:latin typeface="Calibri"/>
-              </a:rPr>
-              <a:t>• Téléchargement PARALLÈLE des stations FR (ThreadPoolExecutor), 5 ans d'historique — jamais fichier par fichier.</a:t>
-            </a:r>
-          </a:p>
-          <a:p>
-            <a:pPr>
-              <a:spcAft>
-                <a:spcPts val="600"/>
-              </a:spcAft>
-            </a:pPr>
-            <a:r>
-              <a:rPr sz="1500">
-                <a:solidFill>
-                  <a:srgbClr val="1F3B57"/>
-                </a:solidFill>
-                <a:latin typeface="Calibri"/>
-              </a:rPr>
-              <a:t>• Nettoyage : parsing ISD, conversion d'unités, valeurs manquantes, timestamp UTC, humidité (Magnus).</a:t>
-            </a:r>
-          </a:p>
-          <a:p>
-            <a:pPr>
-              <a:spcAft>
-                <a:spcPts val="600"/>
-              </a:spcAft>
-            </a:pPr>
-            <a:r>
-              <a:rPr sz="1500">
-                <a:solidFill>
-                  <a:srgbClr val="1F3B57"/>
-                </a:solidFill>
-                <a:latin typeface="Calibri"/>
-              </a:rPr>
-              <a:t>• Questions métier traitées :</a:t>
-            </a:r>
-          </a:p>
-          <a:p>
-            <a:pPr lvl="1">
-              <a:spcAft>
-                <a:spcPts val="600"/>
-              </a:spcAft>
-            </a:pPr>
-            <a:r>
-              <a:rPr sz="1300">
-                <a:solidFill>
-                  <a:srgbClr val="555F66"/>
-                </a:solidFill>
-                <a:latin typeface="Calibri"/>
-              </a:rPr>
-              <a:t>– Périodes anormales (z-score vs normale mensuelle)</a:t>
-            </a:r>
-          </a:p>
-          <a:p>
-            <a:pPr lvl="1">
-              <a:spcAft>
-                <a:spcPts val="600"/>
-              </a:spcAft>
-            </a:pPr>
-            <a:r>
-              <a:rPr sz="1300">
-                <a:solidFill>
-                  <a:srgbClr val="555F66"/>
-                </a:solidFill>
-                <a:latin typeface="Calibri"/>
-              </a:rPr>
-              <a:t>– Corrélation météo ↔ visibilité</a:t>
-            </a:r>
-          </a:p>
-          <a:p>
-            <a:pPr lvl="1">
-              <a:spcAft>
-                <a:spcPts val="600"/>
-              </a:spcAft>
-            </a:pPr>
-            <a:r>
-              <a:rPr sz="1300">
-                <a:solidFill>
-                  <a:srgbClr val="555F66"/>
-                </a:solidFill>
-                <a:latin typeface="Calibri"/>
-              </a:rPr>
-              <a:t>– Évolution saisonnière de la température</a:t>
-            </a:r>
-          </a:p>
-          <a:p>
-            <a:pPr lvl="1">
-              <a:spcAft>
-                <a:spcPts val="600"/>
-              </a:spcAft>
-            </a:pPr>
-            <a:r>
-              <a:rPr sz="1300">
-                <a:solidFill>
-                  <a:srgbClr val="555F66"/>
-                </a:solidFill>
-                <a:latin typeface="Calibri"/>
-              </a:rPr>
-              <a:t>– Jours extrêmes : chaud 37.0°C, froid -5.9°C</a:t>
+              <a:t>Une architecture Lambda (Batch + Temps réel)</a:t>
             </a:r>
           </a:p>
         </p:txBody>
       </p:sp>
       <p:pic>
         <p:nvPicPr>
-          <p:cNvPr id="7" name="Picture 6" descr="weather_saisonnier.png"/>
+          <p:cNvPr id="6" name="Picture 5" descr="architecture_bigdata.png"/>
           <p:cNvPicPr>
             <a:picLocks noChangeAspect="1"/>
           </p:cNvPicPr>
@@ -6032,14 +6161,49 @@
         </p:blipFill>
         <p:spPr>
           <a:xfrm>
-            <a:off x="6500000" y="1700000"/>
-            <a:ext cx="5100000" cy="2550000"/>
+            <a:off x="500000" y="1450000"/>
+            <a:ext cx="11200000" cy="6333333"/>
           </a:xfrm>
           <a:prstGeom prst="rect">
             <a:avLst/>
           </a:prstGeom>
         </p:spPr>
       </p:pic>
+      <p:sp>
+        <p:nvSpPr>
+          <p:cNvPr id="7" name="TextBox 6"/>
+          <p:cNvSpPr txBox="1"/>
+          <p:nvPr/>
+        </p:nvSpPr>
+        <p:spPr>
+          <a:xfrm>
+            <a:off x="500000" y="6350000"/>
+            <a:ext cx="11200000" cy="700000"/>
+          </a:xfrm>
+          <a:prstGeom prst="rect">
+            <a:avLst/>
+          </a:prstGeom>
+          <a:noFill/>
+        </p:spPr>
+        <p:txBody>
+          <a:bodyPr wrap="square" anchor="t">
+            <a:spAutoFit/>
+          </a:bodyPr>
+          <a:lstStyle/>
+          <a:p>
+            <a:pPr algn="l"/>
+            <a:r>
+              <a:rPr sz="1200" b="0">
+                <a:solidFill>
+                  <a:srgbClr val="555F66"/>
+                </a:solidFill>
+                <a:latin typeface="Calibri"/>
+              </a:rPr>
+              <a:t>Ingérer (Kafka) · Stocker (data lake MinIO/Parquet) · Transformer (Spark batch + Structured Streaming) · Restituer (QuestDB + Streamlit/Grafana). Chaque techno open source est choisie face à ses concurrentes.</a:t>
+            </a:r>
+          </a:p>
+        </p:txBody>
+      </p:sp>
     </p:spTree>
   </p:cSld>
   <p:clrMapOvr>
@@ -6176,7 +6340,7 @@
                 </a:solidFill>
                 <a:latin typeface="Calibri"/>
               </a:rPr>
-              <a:t>PARTIE 2 · FLUX STREAMING</a:t>
+              <a:t>PARTIE 1 · FLUX BATCH</a:t>
             </a:r>
           </a:p>
         </p:txBody>
@@ -6211,7 +6375,7 @@
                 </a:solidFill>
                 <a:latin typeface="Calibri"/>
               </a:rPr>
-              <a:t>Mobilité urbaine (CityBikes)</a:t>
+              <a:t>Analyse météorologique urbaine (NOAA)</a:t>
             </a:r>
           </a:p>
         </p:txBody>
@@ -6250,7 +6414,7 @@
                 </a:solidFill>
                 <a:latin typeface="Calibri"/>
               </a:rPr>
-              <a:t>• Récupération automatique toutes les minutes de l'état des stations de tous les réseaux FR (Vélib' inclus).</a:t>
+              <a:t>• Téléchargement PARALLÈLE des stations FR (ThreadPoolExecutor), 5 ans d'historique — jamais fichier par fichier.</a:t>
             </a:r>
           </a:p>
           <a:p>
@@ -6266,7 +6430,7 @@
                 </a:solidFill>
                 <a:latin typeface="Calibri"/>
               </a:rPr>
-              <a:t>• Variables : station_id, nom, lat/lon, bikes_available, free_slots, timestamp.</a:t>
+              <a:t>• Nettoyage : parsing ISD, conversion d'unités, valeurs manquantes, timestamp UTC, humidité (Magnus).</a:t>
             </a:r>
           </a:p>
           <a:p>
@@ -6298,7 +6462,7 @@
                 </a:solidFill>
                 <a:latin typeface="Calibri"/>
               </a:rPr>
-              <a:t>– Stations les plus utilisées (taux d'occupation)</a:t>
+              <a:t>– Périodes anormales (z-score vs normale mensuelle)</a:t>
             </a:r>
           </a:p>
           <a:p>
@@ -6314,7 +6478,7 @@
                 </a:solidFill>
                 <a:latin typeface="Calibri"/>
               </a:rPr>
-              <a:t>– Zones à offre insuffisante (souvent vides)</a:t>
+              <a:t>– Corrélation météo ↔ visibilité</a:t>
             </a:r>
           </a:p>
           <a:p>
@@ -6330,7 +6494,7 @@
                 </a:solidFill>
                 <a:latin typeface="Calibri"/>
               </a:rPr>
-              <a:t>– Pics d'utilisation journaliers</a:t>
+              <a:t>– Évolution saisonnière de la température</a:t>
             </a:r>
           </a:p>
           <a:p>
@@ -6346,30 +6510,14 @@
                 </a:solidFill>
                 <a:latin typeface="Calibri"/>
               </a:rPr>
-              <a:t>– Déséquilibres géographiques</a:t>
-            </a:r>
-          </a:p>
-          <a:p>
-            <a:pPr lvl="1">
-              <a:spcAft>
-                <a:spcPts val="600"/>
-              </a:spcAft>
-            </a:pPr>
-            <a:r>
-              <a:rPr sz="1300">
-                <a:solidFill>
-                  <a:srgbClr val="555F66"/>
-                </a:solidFill>
-                <a:latin typeface="Calibri"/>
-              </a:rPr>
-              <a:t>– Stations critiques à rééquilibrer (pénurie / saturation)</a:t>
+              <a:t>– Jours extrêmes : chaud 37.0°C, froid -5.9°C</a:t>
             </a:r>
           </a:p>
         </p:txBody>
       </p:sp>
       <p:pic>
         <p:nvPicPr>
-          <p:cNvPr id="7" name="Picture 6" descr="mobility_profil_horaire.png"/>
+          <p:cNvPr id="7" name="Picture 6" descr="weather_saisonnier.png"/>
           <p:cNvPicPr>
             <a:picLocks noChangeAspect="1"/>
           </p:cNvPicPr>
@@ -6527,7 +6675,7 @@
                 </a:solidFill>
                 <a:latin typeface="Calibri"/>
               </a:rPr>
-              <a:t>PARTIE 3 · FLUX IoT</a:t>
+              <a:t>PARTIE 2 · FLUX STREAMING</a:t>
             </a:r>
           </a:p>
         </p:txBody>
@@ -6562,7 +6710,7 @@
                 </a:solidFill>
                 <a:latin typeface="Calibri"/>
               </a:rPr>
-              <a:t>Pollution atmosphérique (OpenAQ)</a:t>
+              <a:t>Mobilité urbaine (CityBikes)</a:t>
             </a:r>
           </a:p>
         </p:txBody>
@@ -6601,7 +6749,7 @@
                 </a:solidFill>
                 <a:latin typeface="Calibri"/>
               </a:rPr>
-              <a:t>• Ingestion régulière simulant un flux IoT pour les principales villes.</a:t>
+              <a:t>• Récupération automatique toutes les minutes de l'état des stations de tous les réseaux FR (Vélib' inclus).</a:t>
             </a:r>
           </a:p>
           <a:p>
@@ -6617,7 +6765,7 @@
                 </a:solidFill>
                 <a:latin typeface="Calibri"/>
               </a:rPr>
-              <a:t>• Polluants : PM2.5, PM10, NO₂, O₃, SO₂, CO.</a:t>
+              <a:t>• Variables : station_id, nom, lat/lon, bikes_available, free_slots, timestamp.</a:t>
             </a:r>
           </a:p>
           <a:p>
@@ -6633,22 +6781,6 @@
                 </a:solidFill>
                 <a:latin typeface="Calibri"/>
               </a:rPr>
-              <a:t>• Mode réel via l'API OpenAQ (clé X-API-Key) ou simulateur réaliste avec cycles diurnes + backfill d'historique.</a:t>
-            </a:r>
-          </a:p>
-          <a:p>
-            <a:pPr>
-              <a:spcAft>
-                <a:spcPts val="600"/>
-              </a:spcAft>
-            </a:pPr>
-            <a:r>
-              <a:rPr sz="1500">
-                <a:solidFill>
-                  <a:srgbClr val="1F3B57"/>
-                </a:solidFill>
-                <a:latin typeface="Calibri"/>
-              </a:rPr>
               <a:t>• Questions métier traitées :</a:t>
             </a:r>
           </a:p>
@@ -6665,7 +6797,7 @@
                 </a:solidFill>
                 <a:latin typeface="Calibri"/>
               </a:rPr>
-              <a:t>– Villes les plus polluées par polluant</a:t>
+              <a:t>– Stations les plus utilisées (taux d'occupation)</a:t>
             </a:r>
           </a:p>
           <a:p>
@@ -6681,7 +6813,7 @@
                 </a:solidFill>
                 <a:latin typeface="Calibri"/>
               </a:rPr>
-              <a:t>– Profils horaires (pics trafic NO₂, ozone l'après-midi)</a:t>
+              <a:t>– Zones à offre insuffisante (souvent vides)</a:t>
             </a:r>
           </a:p>
           <a:p>
@@ -6697,7 +6829,7 @@
                 </a:solidFill>
                 <a:latin typeface="Calibri"/>
               </a:rPr>
-              <a:t>– Dépassements des seuils OMS</a:t>
+              <a:t>– Pics d'utilisation journaliers</a:t>
             </a:r>
           </a:p>
           <a:p>
@@ -6713,14 +6845,30 @@
                 </a:solidFill>
                 <a:latin typeface="Calibri"/>
               </a:rPr>
-              <a:t>– Indice de qualité de l'air par ville</a:t>
+              <a:t>– Déséquilibres géographiques</a:t>
+            </a:r>
+          </a:p>
+          <a:p>
+            <a:pPr lvl="1">
+              <a:spcAft>
+                <a:spcPts val="600"/>
+              </a:spcAft>
+            </a:pPr>
+            <a:r>
+              <a:rPr sz="1300">
+                <a:solidFill>
+                  <a:srgbClr val="555F66"/>
+                </a:solidFill>
+                <a:latin typeface="Calibri"/>
+              </a:rPr>
+              <a:t>– Stations critiques à rééquilibrer (pénurie / saturation)</a:t>
             </a:r>
           </a:p>
         </p:txBody>
       </p:sp>
       <p:pic>
         <p:nvPicPr>
-          <p:cNvPr id="7" name="Picture 6" descr="pollution_classement_villes.png"/>
+          <p:cNvPr id="7" name="Picture 6" descr="mobility_profil_horaire.png"/>
           <p:cNvPicPr>
             <a:picLocks noChangeAspect="1"/>
           </p:cNvPicPr>
@@ -6735,7 +6883,7 @@
         <p:spPr>
           <a:xfrm>
             <a:off x="6500000" y="1700000"/>
-            <a:ext cx="5100000" cy="2868750"/>
+            <a:ext cx="5100000" cy="2550000"/>
           </a:xfrm>
           <a:prstGeom prst="rect">
             <a:avLst/>
@@ -6878,7 +7026,7 @@
                 </a:solidFill>
                 <a:latin typeface="Calibri"/>
               </a:rPr>
-              <a:t>PARTIE 4 · ANALYSE CROISÉE</a:t>
+              <a:t>PARTIE 3 · FLUX IoT</a:t>
             </a:r>
           </a:p>
         </p:txBody>
@@ -6913,7 +7061,7 @@
                 </a:solidFill>
                 <a:latin typeface="Calibri"/>
               </a:rPr>
-              <a:t>Météo × Pollution × Mobilité</a:t>
+              <a:t>Pollution atmosphérique (OpenAQ)</a:t>
             </a:r>
           </a:p>
         </p:txBody>
@@ -6952,7 +7100,7 @@
                 </a:solidFill>
                 <a:latin typeface="Calibri"/>
               </a:rPr>
-              <a:t>• Croisement sur le CYCLE DIURNE (robuste aux profondeurs temporelles différentes des 3 flux).</a:t>
+              <a:t>• Ingestion régulière simulant un flux IoT pour les principales villes.</a:t>
             </a:r>
           </a:p>
           <a:p>
@@ -6968,7 +7116,39 @@
                 </a:solidFill>
                 <a:latin typeface="Calibri"/>
               </a:rPr>
-              <a:t>• Relation météo ↔ pollution : forte corrélation ozone/température (signature photochimique).</a:t>
+              <a:t>• Polluants : PM2.5, PM10, NO₂, O₃, SO₂, CO.</a:t>
+            </a:r>
+          </a:p>
+          <a:p>
+            <a:pPr>
+              <a:spcAft>
+                <a:spcPts val="600"/>
+              </a:spcAft>
+            </a:pPr>
+            <a:r>
+              <a:rPr sz="1500">
+                <a:solidFill>
+                  <a:srgbClr val="1F3B57"/>
+                </a:solidFill>
+                <a:latin typeface="Calibri"/>
+              </a:rPr>
+              <a:t>• Mode réel via l'API OpenAQ (clé X-API-Key) ou simulateur réaliste avec cycles diurnes + backfill d'historique.</a:t>
+            </a:r>
+          </a:p>
+          <a:p>
+            <a:pPr>
+              <a:spcAft>
+                <a:spcPts val="600"/>
+              </a:spcAft>
+            </a:pPr>
+            <a:r>
+              <a:rPr sz="1500">
+                <a:solidFill>
+                  <a:srgbClr val="1F3B57"/>
+                </a:solidFill>
+                <a:latin typeface="Calibri"/>
+              </a:rPr>
+              <a:t>• Questions métier traitées :</a:t>
             </a:r>
           </a:p>
           <a:p>
@@ -6984,62 +7164,62 @@
                 </a:solidFill>
                 <a:latin typeface="Calibri"/>
               </a:rPr>
-              <a:t>– O₃ ↔ température : 0.929</a:t>
-            </a:r>
-          </a:p>
-          <a:p>
-            <a:pPr>
+              <a:t>– Villes les plus polluées par polluant</a:t>
+            </a:r>
+          </a:p>
+          <a:p>
+            <a:pPr lvl="1">
               <a:spcAft>
                 <a:spcPts val="600"/>
               </a:spcAft>
             </a:pPr>
             <a:r>
-              <a:rPr sz="1500">
-                <a:solidFill>
-                  <a:srgbClr val="1F3B57"/>
-                </a:solidFill>
-                <a:latin typeface="Calibri"/>
-              </a:rPr>
-              <a:t>• Influence de la météo sur l'usage des vélos.</a:t>
-            </a:r>
-          </a:p>
-          <a:p>
-            <a:pPr>
+              <a:rPr sz="1300">
+                <a:solidFill>
+                  <a:srgbClr val="555F66"/>
+                </a:solidFill>
+                <a:latin typeface="Calibri"/>
+              </a:rPr>
+              <a:t>– Profils horaires (pics trafic NO₂, ozone l'après-midi)</a:t>
+            </a:r>
+          </a:p>
+          <a:p>
+            <a:pPr lvl="1">
               <a:spcAft>
                 <a:spcPts val="600"/>
               </a:spcAft>
             </a:pPr>
             <a:r>
-              <a:rPr sz="1500">
-                <a:solidFill>
-                  <a:srgbClr val="1F3B57"/>
-                </a:solidFill>
-                <a:latin typeface="Calibri"/>
-              </a:rPr>
-              <a:t>• Conditions favorables à la mobilité douce (T 12–25°C, sans pluie, vent &lt; 6 m/s) — surtout en été.</a:t>
-            </a:r>
-          </a:p>
-          <a:p>
-            <a:pPr>
+              <a:rPr sz="1300">
+                <a:solidFill>
+                  <a:srgbClr val="555F66"/>
+                </a:solidFill>
+                <a:latin typeface="Calibri"/>
+              </a:rPr>
+              <a:t>– Dépassements des seuils OMS</a:t>
+            </a:r>
+          </a:p>
+          <a:p>
+            <a:pPr lvl="1">
               <a:spcAft>
                 <a:spcPts val="600"/>
               </a:spcAft>
             </a:pPr>
             <a:r>
-              <a:rPr sz="1500">
-                <a:solidFill>
-                  <a:srgbClr val="1F3B57"/>
-                </a:solidFill>
-                <a:latin typeface="Calibri"/>
-              </a:rPr>
-              <a:t>• Interactions météo × pollution × mobilité sur la journée.</a:t>
+              <a:rPr sz="1300">
+                <a:solidFill>
+                  <a:srgbClr val="555F66"/>
+                </a:solidFill>
+                <a:latin typeface="Calibri"/>
+              </a:rPr>
+              <a:t>– Indice de qualité de l'air par ville</a:t>
             </a:r>
           </a:p>
         </p:txBody>
       </p:sp>
       <p:pic>
         <p:nvPicPr>
-          <p:cNvPr id="7" name="Picture 6" descr="cross_cycle_diurne.png"/>
+          <p:cNvPr id="7" name="Picture 6" descr="pollution_classement_villes.png"/>
           <p:cNvPicPr>
             <a:picLocks noChangeAspect="1"/>
           </p:cNvPicPr>
@@ -7053,8 +7233,8 @@
         </p:blipFill>
         <p:spPr>
           <a:xfrm>
-            <a:off x="6500000" y="1650000"/>
-            <a:ext cx="5100000" cy="2550000"/>
+            <a:off x="6500000" y="1700000"/>
+            <a:ext cx="5100000" cy="2868750"/>
           </a:xfrm>
           <a:prstGeom prst="rect">
             <a:avLst/>
@@ -7197,7 +7377,7 @@
                 </a:solidFill>
                 <a:latin typeface="Calibri"/>
               </a:rPr>
-              <a:t>RESTITUTION</a:t>
+              <a:t>PARTIE 4 · ANALYSE CROISÉE</a:t>
             </a:r>
           </a:p>
         </p:txBody>
@@ -7232,7 +7412,7 @@
                 </a:solidFill>
                 <a:latin typeface="Calibri"/>
               </a:rPr>
-              <a:t>Tableau de bord interactif (Streamlit)</a:t>
+              <a:t>Météo × Pollution × Mobilité</a:t>
             </a:r>
           </a:p>
         </p:txBody>
@@ -7245,8 +7425,8 @@
         </p:nvSpPr>
         <p:spPr>
           <a:xfrm>
-            <a:off x="600000" y="1600000"/>
-            <a:ext cx="11000000" cy="3000000"/>
+            <a:off x="600000" y="1550000"/>
+            <a:ext cx="5600000" cy="4500000"/>
           </a:xfrm>
           <a:prstGeom prst="rect">
             <a:avLst/>
@@ -7265,13 +7445,13 @@
               </a:spcAft>
             </a:pPr>
             <a:r>
-              <a:rPr sz="1600">
+              <a:rPr sz="1500">
                 <a:solidFill>
                   <a:srgbClr val="1F3B57"/>
                 </a:solidFill>
                 <a:latin typeface="Calibri"/>
               </a:rPr>
-              <a:t>• 4 onglets : Météo · Mobilité · Pollution · Analyse croisée.</a:t>
+              <a:t>• Croisement sur le CYCLE DIURNE (robuste aux profondeurs temporelles différentes des 3 flux).</a:t>
             </a:r>
           </a:p>
           <a:p>
@@ -7281,13 +7461,29 @@
               </a:spcAft>
             </a:pPr>
             <a:r>
-              <a:rPr sz="1600">
+              <a:rPr sz="1500">
                 <a:solidFill>
                   <a:srgbClr val="1F3B57"/>
                 </a:solidFill>
                 <a:latin typeface="Calibri"/>
               </a:rPr>
-              <a:t>• Filtres interactifs (menus déroulants à cases à cocher) : villes, polluants, réseaux — les graphiques se recalculent en direct.</a:t>
+              <a:t>• Relation météo ↔ pollution : forte corrélation ozone/température (signature photochimique).</a:t>
+            </a:r>
+          </a:p>
+          <a:p>
+            <a:pPr lvl="1">
+              <a:spcAft>
+                <a:spcPts val="600"/>
+              </a:spcAft>
+            </a:pPr>
+            <a:r>
+              <a:rPr sz="1300">
+                <a:solidFill>
+                  <a:srgbClr val="555F66"/>
+                </a:solidFill>
+                <a:latin typeface="Calibri"/>
+              </a:rPr>
+              <a:t>– O₃ ↔ température : 0.929</a:t>
             </a:r>
           </a:p>
           <a:p>
@@ -7297,13 +7493,13 @@
               </a:spcAft>
             </a:pPr>
             <a:r>
-              <a:rPr sz="1600">
+              <a:rPr sz="1500">
                 <a:solidFill>
                   <a:srgbClr val="1F3B57"/>
                 </a:solidFill>
                 <a:latin typeface="Calibri"/>
               </a:rPr>
-              <a:t>• KPIs, carte des stations vélos, classements, profils horaires, matrice de corrélation.</a:t>
+              <a:t>• Influence de la météo sur l'usage des vélos.</a:t>
             </a:r>
           </a:p>
           <a:p>
@@ -7313,17 +7509,57 @@
               </a:spcAft>
             </a:pPr>
             <a:r>
-              <a:rPr sz="1600">
+              <a:rPr sz="1500">
                 <a:solidFill>
                   <a:srgbClr val="1F3B57"/>
                 </a:solidFill>
                 <a:latin typeface="Calibri"/>
               </a:rPr>
-              <a:t>• Lancement : python -m urbanhub.cli dashboard  →  http://localhost:8501</a:t>
-            </a:r>
-          </a:p>
-        </p:txBody>
-      </p:sp>
+              <a:t>• Conditions favorables à la mobilité douce (T 12–25°C, sans pluie, vent &lt; 6 m/s) — surtout en été.</a:t>
+            </a:r>
+          </a:p>
+          <a:p>
+            <a:pPr>
+              <a:spcAft>
+                <a:spcPts val="600"/>
+              </a:spcAft>
+            </a:pPr>
+            <a:r>
+              <a:rPr sz="1500">
+                <a:solidFill>
+                  <a:srgbClr val="1F3B57"/>
+                </a:solidFill>
+                <a:latin typeface="Calibri"/>
+              </a:rPr>
+              <a:t>• Interactions météo × pollution × mobilité sur la journée.</a:t>
+            </a:r>
+          </a:p>
+        </p:txBody>
+      </p:sp>
+      <p:pic>
+        <p:nvPicPr>
+          <p:cNvPr id="7" name="Picture 6" descr="cross_cycle_diurne.png"/>
+          <p:cNvPicPr>
+            <a:picLocks noChangeAspect="1"/>
+          </p:cNvPicPr>
+          <p:nvPr/>
+        </p:nvPicPr>
+        <p:blipFill>
+          <a:blip r:embed="rId2"/>
+          <a:stretch>
+            <a:fillRect/>
+          </a:stretch>
+        </p:blipFill>
+        <p:spPr>
+          <a:xfrm>
+            <a:off x="6500000" y="1650000"/>
+            <a:ext cx="5100000" cy="2550000"/>
+          </a:xfrm>
+          <a:prstGeom prst="rect">
+            <a:avLst/>
+          </a:prstGeom>
+        </p:spPr>
+      </p:pic>
     </p:spTree>
   </p:cSld>
   <p:clrMapOvr>

</xml_diff>